<commit_message>
Add AGENTS.md with conversion workflow guidance
</commit_message>
<xml_diff>
--- a/mermaid-native.pptx
+++ b/mermaid-native.pptx
@@ -228,35 +228,35 @@
         </p:nvSpPr>
         <p:spPr>
           <a:xfrm>
-            <a:off x="2574354" y="1467551"/>
-            <a:ext cx="652930" cy="1"/>
+            <a:off x="2497103" y="868727"/>
+            <a:ext cx="1" cy="324890"/>
           </a:xfrm>
           <a:custGeom>
             <a:avLst/>
             <a:gdLst/>
             <a:ahLst/>
             <a:cxnLst/>
-            <a:rect l="0" t="0" r="652930" b="1"/>
+            <a:rect l="0" t="0" r="1" b="324890"/>
             <a:pathLst>
-              <a:path w="652930" h="1">
+              <a:path w="1" h="324890">
                 <a:moveTo>
                   <a:pt x="0" y="0"/>
                 </a:moveTo>
                 <a:lnTo>
-                  <a:pt x="76058" y="0"/>
-                </a:lnTo>
-                <a:cubicBezTo>
-                  <a:pt x="152116" y="0"/>
-                  <a:pt x="304232" y="0"/>
-                  <a:pt x="413054" y="0"/>
-                </a:cubicBezTo>
-                <a:cubicBezTo>
-                  <a:pt x="521876" y="0"/>
-                  <a:pt x="587403" y="0"/>
-                  <a:pt x="620166" y="0"/>
-                </a:cubicBezTo>
-                <a:lnTo>
-                  <a:pt x="652930" y="0"/>
+                  <a:pt x="0" y="29431"/>
+                </a:lnTo>
+                <a:cubicBezTo>
+                  <a:pt x="0" y="58855"/>
+                  <a:pt x="0" y="117716"/>
+                  <a:pt x="0" y="171860"/>
+                </a:cubicBezTo>
+                <a:cubicBezTo>
+                  <a:pt x="0" y="226010"/>
+                  <a:pt x="0" y="275450"/>
+                  <a:pt x="0" y="300170"/>
+                </a:cubicBezTo>
+                <a:lnTo>
+                  <a:pt x="0" y="324890"/>
                 </a:lnTo>
               </a:path>
             </a:pathLst>
@@ -278,35 +278,35 @@
         </p:nvSpPr>
         <p:spPr>
           <a:xfrm>
-            <a:off x="2645516" y="2441094"/>
-            <a:ext cx="813405" cy="217091"/>
+            <a:off x="2497103" y="1603261"/>
+            <a:ext cx="1" cy="324889"/>
           </a:xfrm>
           <a:custGeom>
             <a:avLst/>
             <a:gdLst/>
             <a:ahLst/>
             <a:cxnLst/>
-            <a:rect l="0" t="0" r="813405" b="217091"/>
+            <a:rect l="0" t="0" r="1" b="324889"/>
             <a:pathLst>
-              <a:path w="813405" h="217091">
+              <a:path w="1" h="324889">
                 <a:moveTo>
                   <a:pt x="0" y="0"/>
                 </a:moveTo>
                 <a:lnTo>
-                  <a:pt x="64198" y="0"/>
-                </a:lnTo>
-                <a:cubicBezTo>
-                  <a:pt x="128396" y="0"/>
-                  <a:pt x="256791" y="0"/>
-                  <a:pt x="392357" y="36181"/>
-                </a:cubicBezTo>
-                <a:cubicBezTo>
-                  <a:pt x="527933" y="72361"/>
-                  <a:pt x="670669" y="144731"/>
-                  <a:pt x="742037" y="180911"/>
-                </a:cubicBezTo>
-                <a:lnTo>
-                  <a:pt x="813405" y="217091"/>
+                  <a:pt x="0" y="29430"/>
+                </a:lnTo>
+                <a:cubicBezTo>
+                  <a:pt x="0" y="58854"/>
+                  <a:pt x="0" y="117716"/>
+                  <a:pt x="0" y="171859"/>
+                </a:cubicBezTo>
+                <a:cubicBezTo>
+                  <a:pt x="0" y="226010"/>
+                  <a:pt x="0" y="275450"/>
+                  <a:pt x="0" y="300169"/>
+                </a:cubicBezTo>
+                <a:lnTo>
+                  <a:pt x="0" y="324889"/>
                 </a:lnTo>
               </a:path>
             </a:pathLst>
@@ -328,35 +328,65 @@
         </p:nvSpPr>
         <p:spPr>
           <a:xfrm>
-            <a:off x="2734521" y="3197547"/>
-            <a:ext cx="724400" cy="217091"/>
+            <a:off x="1635438" y="2337794"/>
+            <a:ext cx="498148" cy="2868254"/>
           </a:xfrm>
           <a:custGeom>
             <a:avLst/>
             <a:gdLst/>
             <a:ahLst/>
             <a:cxnLst/>
-            <a:rect l="0" t="0" r="724400" b="217091"/>
+            <a:rect l="0" t="0" r="498148" b="2868254"/>
             <a:pathLst>
-              <a:path w="724400" h="217091">
+              <a:path w="498148" h="2868254">
                 <a:moveTo>
-                  <a:pt x="0" y="217091"/>
+                  <a:pt x="498148" y="0"/>
                 </a:moveTo>
                 <a:lnTo>
-                  <a:pt x="49360" y="217091"/>
-                </a:lnTo>
-                <a:cubicBezTo>
-                  <a:pt x="98730" y="217091"/>
-                  <a:pt x="197461" y="217091"/>
-                  <a:pt x="318189" y="180911"/>
-                </a:cubicBezTo>
-                <a:cubicBezTo>
-                  <a:pt x="438928" y="144731"/>
-                  <a:pt x="581664" y="72361"/>
-                  <a:pt x="653032" y="36180"/>
-                </a:cubicBezTo>
-                <a:lnTo>
-                  <a:pt x="724400" y="0"/>
+                  <a:pt x="415125" y="43556"/>
+                </a:lnTo>
+                <a:cubicBezTo>
+                  <a:pt x="332101" y="87106"/>
+                  <a:pt x="166047" y="174219"/>
+                  <a:pt x="83024" y="293107"/>
+                </a:cubicBezTo>
+                <a:cubicBezTo>
+                  <a:pt x="0" y="411996"/>
+                  <a:pt x="0" y="562674"/>
+                  <a:pt x="0" y="699219"/>
+                </a:cubicBezTo>
+                <a:cubicBezTo>
+                  <a:pt x="0" y="835765"/>
+                  <a:pt x="0" y="958192"/>
+                  <a:pt x="0" y="1080612"/>
+                </a:cubicBezTo>
+                <a:cubicBezTo>
+                  <a:pt x="0" y="1203032"/>
+                  <a:pt x="0" y="1325459"/>
+                  <a:pt x="0" y="1447879"/>
+                </a:cubicBezTo>
+                <a:cubicBezTo>
+                  <a:pt x="0" y="1570298"/>
+                  <a:pt x="0" y="1692725"/>
+                  <a:pt x="0" y="1815145"/>
+                </a:cubicBezTo>
+                <a:cubicBezTo>
+                  <a:pt x="0" y="1937565"/>
+                  <a:pt x="0" y="2059992"/>
+                  <a:pt x="0" y="2196538"/>
+                </a:cubicBezTo>
+                <a:cubicBezTo>
+                  <a:pt x="0" y="2333083"/>
+                  <a:pt x="0" y="2483761"/>
+                  <a:pt x="9133" y="2598066"/>
+                </a:cubicBezTo>
+                <a:cubicBezTo>
+                  <a:pt x="18265" y="2712371"/>
+                  <a:pt x="36536" y="2790309"/>
+                  <a:pt x="45669" y="2829282"/>
+                </a:cubicBezTo>
+                <a:lnTo>
+                  <a:pt x="54801" y="2868254"/>
                 </a:lnTo>
               </a:path>
             </a:pathLst>
@@ -378,35 +408,35 @@
         </p:nvSpPr>
         <p:spPr>
           <a:xfrm>
-            <a:off x="2796678" y="4388182"/>
-            <a:ext cx="662243" cy="217091"/>
+            <a:off x="2740050" y="2337794"/>
+            <a:ext cx="332920" cy="494398"/>
           </a:xfrm>
           <a:custGeom>
             <a:avLst/>
             <a:gdLst/>
             <a:ahLst/>
             <a:cxnLst/>
-            <a:rect l="0" t="0" r="662243" b="217091"/>
+            <a:rect l="0" t="0" r="332920" b="494398"/>
             <a:pathLst>
-              <a:path w="662243" h="217091">
+              <a:path w="332920" h="494398">
                 <a:moveTo>
                   <a:pt x="0" y="0"/>
                 </a:moveTo>
                 <a:lnTo>
-                  <a:pt x="39007" y="0"/>
-                </a:lnTo>
-                <a:cubicBezTo>
-                  <a:pt x="78014" y="0"/>
-                  <a:pt x="156020" y="0"/>
-                  <a:pt x="266395" y="36180"/>
-                </a:cubicBezTo>
-                <a:cubicBezTo>
-                  <a:pt x="376771" y="72360"/>
-                  <a:pt x="519507" y="144730"/>
-                  <a:pt x="590875" y="180910"/>
-                </a:cubicBezTo>
-                <a:lnTo>
-                  <a:pt x="662243" y="217091"/>
+                  <a:pt x="55485" y="43556"/>
+                </a:lnTo>
+                <a:cubicBezTo>
+                  <a:pt x="110971" y="87106"/>
+                  <a:pt x="221949" y="174219"/>
+                  <a:pt x="277434" y="256614"/>
+                </a:cubicBezTo>
+                <a:cubicBezTo>
+                  <a:pt x="332920" y="339015"/>
+                  <a:pt x="332920" y="416707"/>
+                  <a:pt x="332920" y="455552"/>
+                </a:cubicBezTo>
+                <a:lnTo>
+                  <a:pt x="332920" y="494398"/>
                 </a:lnTo>
               </a:path>
             </a:pathLst>
@@ -428,35 +458,35 @@
         </p:nvSpPr>
         <p:spPr>
           <a:xfrm>
-            <a:off x="2776935" y="5144634"/>
-            <a:ext cx="681986" cy="217091"/>
+            <a:off x="3072970" y="3241835"/>
+            <a:ext cx="1" cy="324890"/>
           </a:xfrm>
           <a:custGeom>
             <a:avLst/>
             <a:gdLst/>
             <a:ahLst/>
             <a:cxnLst/>
-            <a:rect l="0" t="0" r="681986" b="217091"/>
+            <a:rect l="0" t="0" r="1" b="324890"/>
             <a:pathLst>
-              <a:path w="681986" h="217091">
+              <a:path w="1" h="324890">
                 <a:moveTo>
-                  <a:pt x="0" y="217091"/>
+                  <a:pt x="0" y="0"/>
                 </a:moveTo>
                 <a:lnTo>
-                  <a:pt x="42293" y="217091"/>
-                </a:lnTo>
-                <a:cubicBezTo>
-                  <a:pt x="84586" y="217091"/>
-                  <a:pt x="169182" y="217091"/>
-                  <a:pt x="282843" y="180911"/>
-                </a:cubicBezTo>
-                <a:cubicBezTo>
-                  <a:pt x="396514" y="144731"/>
-                  <a:pt x="539250" y="72361"/>
-                  <a:pt x="610618" y="36181"/>
-                </a:cubicBezTo>
-                <a:lnTo>
-                  <a:pt x="681986" y="0"/>
+                  <a:pt x="0" y="29431"/>
+                </a:lnTo>
+                <a:cubicBezTo>
+                  <a:pt x="0" y="58855"/>
+                  <a:pt x="0" y="117716"/>
+                  <a:pt x="0" y="171860"/>
+                </a:cubicBezTo>
+                <a:cubicBezTo>
+                  <a:pt x="0" y="226011"/>
+                  <a:pt x="0" y="275450"/>
+                  <a:pt x="0" y="300170"/>
+                </a:cubicBezTo>
+                <a:lnTo>
+                  <a:pt x="0" y="324890"/>
                 </a:lnTo>
               </a:path>
             </a:pathLst>
@@ -478,35 +508,35 @@
         </p:nvSpPr>
         <p:spPr>
           <a:xfrm>
-            <a:off x="4717002" y="1467551"/>
-            <a:ext cx="1010697" cy="1176321"/>
+            <a:off x="3072970" y="3976369"/>
+            <a:ext cx="1" cy="324889"/>
           </a:xfrm>
           <a:custGeom>
             <a:avLst/>
             <a:gdLst/>
             <a:ahLst/>
             <a:cxnLst/>
-            <a:rect l="0" t="0" r="1010697" b="1176321"/>
+            <a:rect l="0" t="0" r="1" b="324889"/>
             <a:pathLst>
-              <a:path w="1010697" h="1176321">
+              <a:path w="1" h="324889">
                 <a:moveTo>
                   <a:pt x="0" y="0"/>
                 </a:moveTo>
                 <a:lnTo>
-                  <a:pt x="39007" y="0"/>
-                </a:lnTo>
-                <a:cubicBezTo>
-                  <a:pt x="78005" y="0"/>
-                  <a:pt x="156020" y="0"/>
-                  <a:pt x="324471" y="196057"/>
-                </a:cubicBezTo>
-                <a:cubicBezTo>
-                  <a:pt x="492913" y="392104"/>
-                  <a:pt x="751810" y="784217"/>
-                  <a:pt x="881254" y="980265"/>
-                </a:cubicBezTo>
-                <a:lnTo>
-                  <a:pt x="1010697" y="1176321"/>
+                  <a:pt x="0" y="29430"/>
+                </a:lnTo>
+                <a:cubicBezTo>
+                  <a:pt x="0" y="58854"/>
+                  <a:pt x="0" y="117716"/>
+                  <a:pt x="0" y="171859"/>
+                </a:cubicBezTo>
+                <a:cubicBezTo>
+                  <a:pt x="0" y="226010"/>
+                  <a:pt x="0" y="275450"/>
+                  <a:pt x="0" y="300170"/>
+                </a:cubicBezTo>
+                <a:lnTo>
+                  <a:pt x="0" y="324889"/>
                 </a:lnTo>
               </a:path>
             </a:pathLst>
@@ -528,35 +558,85 @@
         </p:nvSpPr>
         <p:spPr>
           <a:xfrm>
-            <a:off x="4686429" y="2927866"/>
-            <a:ext cx="461179" cy="1"/>
+            <a:off x="2006547" y="4710902"/>
+            <a:ext cx="747607" cy="505204"/>
           </a:xfrm>
           <a:custGeom>
             <a:avLst/>
             <a:gdLst/>
             <a:ahLst/>
             <a:cxnLst/>
-            <a:rect l="0" t="0" r="461179" b="1"/>
+            <a:rect l="0" t="0" r="747607" b="505204"/>
             <a:pathLst>
-              <a:path w="461179" h="1">
+              <a:path w="747607" h="505204">
+                <a:moveTo>
+                  <a:pt x="747607" y="0"/>
+                </a:moveTo>
+                <a:lnTo>
+                  <a:pt x="674789" y="43557"/>
+                </a:lnTo>
+                <a:cubicBezTo>
+                  <a:pt x="601972" y="87106"/>
+                  <a:pt x="456336" y="174219"/>
+                  <a:pt x="331734" y="258415"/>
+                </a:cubicBezTo>
+                <a:cubicBezTo>
+                  <a:pt x="207132" y="342618"/>
+                  <a:pt x="103569" y="423911"/>
+                  <a:pt x="51785" y="464557"/>
+                </a:cubicBezTo>
+                <a:lnTo>
+                  <a:pt x="0" y="505204"/>
+                </a:lnTo>
+              </a:path>
+            </a:pathLst>
+          </a:custGeom>
+          <a:noFill/>
+          <a:ln w="9525">
+            <a:solidFill>
+              <a:srgbClr val="333333"/>
+            </a:solidFill>
+            <a:tailEnd type="triangle" w="med" len="med"/>
+          </a:ln>
+        </p:spPr>
+      </p:sp>
+      <p:sp>
+        <p:nvSpPr>
+          <p:cNvPr id="9" name="Mermaid Edge 9"/>
+          <p:cNvSpPr/>
+          <p:nvPr/>
+        </p:nvSpPr>
+        <p:spPr>
+          <a:xfrm>
+            <a:off x="3148846" y="4710902"/>
+            <a:ext cx="103978" cy="494398"/>
+          </a:xfrm>
+          <a:custGeom>
+            <a:avLst/>
+            <a:gdLst/>
+            <a:ahLst/>
+            <a:cxnLst/>
+            <a:rect l="0" t="0" r="103978" b="494398"/>
+            <a:pathLst>
+              <a:path w="103978" h="494398">
                 <a:moveTo>
                   <a:pt x="0" y="0"/>
                 </a:moveTo>
                 <a:lnTo>
-                  <a:pt x="44100" y="0"/>
-                </a:lnTo>
-                <a:cubicBezTo>
-                  <a:pt x="88199" y="0"/>
-                  <a:pt x="176399" y="0"/>
-                  <a:pt x="253262" y="0"/>
-                </a:cubicBezTo>
-                <a:cubicBezTo>
-                  <a:pt x="330125" y="0"/>
-                  <a:pt x="395652" y="0"/>
-                  <a:pt x="428415" y="0"/>
-                </a:cubicBezTo>
-                <a:lnTo>
-                  <a:pt x="461179" y="0"/>
+                  <a:pt x="17332" y="43557"/>
+                </a:lnTo>
+                <a:cubicBezTo>
+                  <a:pt x="34657" y="87106"/>
+                  <a:pt x="69321" y="174219"/>
+                  <a:pt x="86646" y="256614"/>
+                </a:cubicBezTo>
+                <a:cubicBezTo>
+                  <a:pt x="103978" y="339016"/>
+                  <a:pt x="103978" y="416707"/>
+                  <a:pt x="103978" y="455552"/>
+                </a:cubicBezTo>
+                <a:lnTo>
+                  <a:pt x="103978" y="494398"/>
                 </a:lnTo>
               </a:path>
             </a:pathLst>
@@ -572,41 +652,41 @@
       </p:sp>
       <p:sp>
         <p:nvSpPr>
-          <p:cNvPr id="9" name="Mermaid Edge 9"/>
-          <p:cNvSpPr/>
-          <p:nvPr/>
-        </p:nvSpPr>
-        <p:spPr>
-          <a:xfrm>
-            <a:off x="4656811" y="3214172"/>
-            <a:ext cx="1116626" cy="1660782"/>
+          <p:cNvPr id="10" name="Mermaid Edge 10"/>
+          <p:cNvSpPr/>
+          <p:nvPr/>
+        </p:nvSpPr>
+        <p:spPr>
+          <a:xfrm>
+            <a:off x="1741381" y="5614943"/>
+            <a:ext cx="337920" cy="340796"/>
           </a:xfrm>
           <a:custGeom>
             <a:avLst/>
             <a:gdLst/>
             <a:ahLst/>
             <a:cxnLst/>
-            <a:rect l="0" t="0" r="1116626" b="1660782"/>
+            <a:rect l="0" t="0" r="337920" b="340796"/>
             <a:pathLst>
-              <a:path w="1116626" h="1660782">
+              <a:path w="337920" h="340796">
                 <a:moveTo>
-                  <a:pt x="0" y="1660782"/>
+                  <a:pt x="0" y="0"/>
                 </a:moveTo>
                 <a:lnTo>
-                  <a:pt x="49042" y="1660782"/>
-                </a:lnTo>
-                <a:cubicBezTo>
-                  <a:pt x="98075" y="1660782"/>
-                  <a:pt x="196141" y="1660782"/>
-                  <a:pt x="382247" y="1383986"/>
-                </a:cubicBezTo>
-                <a:cubicBezTo>
-                  <a:pt x="568353" y="1107191"/>
-                  <a:pt x="842489" y="553591"/>
-                  <a:pt x="979553" y="276796"/>
-                </a:cubicBezTo>
-                <a:lnTo>
-                  <a:pt x="1116626" y="0"/>
+                  <a:pt x="0" y="29431"/>
+                </a:lnTo>
+                <a:cubicBezTo>
+                  <a:pt x="0" y="58855"/>
+                  <a:pt x="0" y="117716"/>
+                  <a:pt x="56319" y="174516"/>
+                </a:cubicBezTo>
+                <a:cubicBezTo>
+                  <a:pt x="112638" y="231315"/>
+                  <a:pt x="225275" y="286052"/>
+                  <a:pt x="281601" y="313420"/>
+                </a:cubicBezTo>
+                <a:lnTo>
+                  <a:pt x="337920" y="340796"/>
                 </a:lnTo>
               </a:path>
             </a:pathLst>
@@ -622,41 +702,41 @@
       </p:sp>
       <p:sp>
         <p:nvSpPr>
-          <p:cNvPr id="10" name="Mermaid Edge 10"/>
-          <p:cNvSpPr/>
-          <p:nvPr/>
-        </p:nvSpPr>
-        <p:spPr>
-          <a:xfrm>
-            <a:off x="6415845" y="2441094"/>
-            <a:ext cx="660128" cy="234025"/>
+          <p:cNvPr id="11" name="Mermaid Edge 11"/>
+          <p:cNvSpPr/>
+          <p:nvPr/>
+        </p:nvSpPr>
+        <p:spPr>
+          <a:xfrm>
+            <a:off x="2914904" y="5614943"/>
+            <a:ext cx="337920" cy="340796"/>
           </a:xfrm>
           <a:custGeom>
             <a:avLst/>
             <a:gdLst/>
             <a:ahLst/>
             <a:cxnLst/>
-            <a:rect l="0" t="0" r="660128" b="234025"/>
+            <a:rect l="0" t="0" r="337920" b="340796"/>
             <a:pathLst>
-              <a:path w="660128" h="234025">
+              <a:path w="337920" h="340796">
                 <a:moveTo>
-                  <a:pt x="0" y="234025"/>
+                  <a:pt x="337920" y="0"/>
                 </a:moveTo>
                 <a:lnTo>
-                  <a:pt x="77256" y="195018"/>
-                </a:lnTo>
-                <a:cubicBezTo>
-                  <a:pt x="154513" y="156020"/>
-                  <a:pt x="309035" y="78006"/>
-                  <a:pt x="419054" y="39008"/>
-                </a:cubicBezTo>
-                <a:cubicBezTo>
-                  <a:pt x="529074" y="0"/>
-                  <a:pt x="594601" y="0"/>
-                  <a:pt x="627365" y="0"/>
-                </a:cubicBezTo>
-                <a:lnTo>
-                  <a:pt x="660128" y="0"/>
+                  <a:pt x="337920" y="29431"/>
+                </a:lnTo>
+                <a:cubicBezTo>
+                  <a:pt x="337920" y="58855"/>
+                  <a:pt x="337920" y="117716"/>
+                  <a:pt x="281602" y="174516"/>
+                </a:cubicBezTo>
+                <a:cubicBezTo>
+                  <a:pt x="225283" y="231315"/>
+                  <a:pt x="112645" y="286052"/>
+                  <a:pt x="56319" y="313420"/>
+                </a:cubicBezTo>
+                <a:lnTo>
+                  <a:pt x="0" y="340796"/>
                 </a:lnTo>
               </a:path>
             </a:pathLst>
@@ -672,138 +752,14 @@
       </p:sp>
       <p:sp>
         <p:nvSpPr>
-          <p:cNvPr id="11" name="Mermaid Edge 11"/>
-          <p:cNvSpPr/>
-          <p:nvPr/>
-        </p:nvSpPr>
-        <p:spPr>
-          <a:xfrm>
-            <a:off x="6415845" y="3180613"/>
-            <a:ext cx="938103" cy="234025"/>
-          </a:xfrm>
-          <a:custGeom>
-            <a:avLst/>
-            <a:gdLst/>
-            <a:ahLst/>
-            <a:cxnLst/>
-            <a:rect l="0" t="0" r="938103" b="234025"/>
-            <a:pathLst>
-              <a:path w="938103" h="234025">
-                <a:moveTo>
-                  <a:pt x="0" y="0"/>
-                </a:moveTo>
-                <a:lnTo>
-                  <a:pt x="77256" y="39007"/>
-                </a:lnTo>
-                <a:cubicBezTo>
-                  <a:pt x="154513" y="78005"/>
-                  <a:pt x="309035" y="156020"/>
-                  <a:pt x="465382" y="195018"/>
-                </a:cubicBezTo>
-                <a:cubicBezTo>
-                  <a:pt x="621729" y="234025"/>
-                  <a:pt x="779921" y="234025"/>
-                  <a:pt x="859012" y="234025"/>
-                </a:cubicBezTo>
-                <a:lnTo>
-                  <a:pt x="938103" y="234025"/>
-                </a:lnTo>
-              </a:path>
-            </a:pathLst>
-          </a:custGeom>
-          <a:noFill/>
-          <a:ln w="9525">
-            <a:solidFill>
-              <a:srgbClr val="333333"/>
-            </a:solidFill>
-            <a:tailEnd type="triangle" w="med" len="med"/>
-          </a:ln>
-        </p:spPr>
-      </p:sp>
-      <p:sp>
-        <p:nvSpPr>
-          <p:cNvPr id="12" name="Mermaid Edge 12"/>
-          <p:cNvSpPr/>
-          <p:nvPr/>
-        </p:nvSpPr>
-        <p:spPr>
-          <a:xfrm>
-            <a:off x="8789326" y="2441094"/>
-            <a:ext cx="430605" cy="1"/>
-          </a:xfrm>
-          <a:custGeom>
-            <a:avLst/>
-            <a:gdLst/>
-            <a:ahLst/>
-            <a:cxnLst/>
-            <a:rect l="0" t="0" r="430605" b="1"/>
-            <a:pathLst>
-              <a:path w="430605" h="1">
-                <a:moveTo>
-                  <a:pt x="0" y="0"/>
-                </a:moveTo>
-                <a:lnTo>
-                  <a:pt x="39007" y="0"/>
-                </a:lnTo>
-                <a:cubicBezTo>
-                  <a:pt x="78014" y="0"/>
-                  <a:pt x="156019" y="0"/>
-                  <a:pt x="227790" y="0"/>
-                </a:cubicBezTo>
-                <a:cubicBezTo>
-                  <a:pt x="299552" y="0"/>
-                  <a:pt x="365079" y="0"/>
-                  <a:pt x="397842" y="0"/>
-                </a:cubicBezTo>
-                <a:lnTo>
-                  <a:pt x="430605" y="0"/>
-                </a:lnTo>
-              </a:path>
-            </a:pathLst>
-          </a:custGeom>
-          <a:noFill/>
-          <a:ln w="9525">
-            <a:solidFill>
-              <a:srgbClr val="333333"/>
-            </a:solidFill>
-            <a:tailEnd type="triangle" w="med" len="med"/>
-          </a:ln>
-        </p:spPr>
-      </p:sp>
-      <p:sp>
-        <p:nvSpPr>
-          <p:cNvPr id="13" name="Rect 13"/>
-          <p:cNvSpPr/>
-          <p:nvPr/>
-        </p:nvSpPr>
-        <p:spPr>
-          <a:xfrm>
-            <a:off x="1059193" y="1214804"/>
-            <a:ext cx="1515165" cy="505494"/>
-          </a:xfrm>
-          <a:prstGeom prst="rect">
-            <a:avLst/>
-          </a:prstGeom>
-          <a:solidFill>
-            <a:srgbClr val="ECECFF"/>
-          </a:solidFill>
-          <a:ln w="9525">
-            <a:solidFill>
-              <a:srgbClr val="9370DB"/>
-            </a:solidFill>
-          </a:ln>
-        </p:spPr>
-      </p:sp>
-      <p:sp>
-        <p:nvSpPr>
-          <p:cNvPr id="14" name="Text 14"/>
+          <p:cNvPr id="12" name="Text 12"/>
           <p:cNvSpPr txBox="1"/>
           <p:nvPr/>
         </p:nvSpPr>
         <p:spPr>
           <a:xfrm>
-            <a:off x="1248001" y="1355219"/>
-            <a:ext cx="1137548" cy="224664"/>
+            <a:off x="1523281" y="3700919"/>
+            <a:ext cx="224315" cy="169507"/>
           </a:xfrm>
           <a:prstGeom prst="rect">
             <a:avLst/>
@@ -829,7 +785,7 @@
                 <a:ea typeface="trebuchet ms"/>
                 <a:cs typeface="trebuchet ms"/>
               </a:rPr>
-              <a:t>STEP / CAD 檔</a:t>
+              <a:t>OK</a:t>
             </a:r>
             <a:endParaRPr lang="en-US" sz="1200"/>
           </a:p>
@@ -837,38 +793,14 @@
       </p:sp>
       <p:sp>
         <p:nvSpPr>
-          <p:cNvPr id="15" name="Rect 15"/>
-          <p:cNvSpPr/>
-          <p:nvPr/>
-        </p:nvSpPr>
-        <p:spPr>
-          <a:xfrm>
-            <a:off x="3264731" y="1214804"/>
-            <a:ext cx="1452271" cy="505494"/>
-          </a:xfrm>
-          <a:prstGeom prst="rect">
-            <a:avLst/>
-          </a:prstGeom>
-          <a:solidFill>
-            <a:srgbClr val="ECECFF"/>
-          </a:solidFill>
-          <a:ln w="9525">
-            <a:solidFill>
-              <a:srgbClr val="9370DB"/>
-            </a:solidFill>
-          </a:ln>
-        </p:spPr>
-      </p:sp>
-      <p:sp>
-        <p:nvSpPr>
-          <p:cNvPr id="16" name="Text 16"/>
+          <p:cNvPr id="13" name="Text 13"/>
           <p:cNvSpPr txBox="1"/>
           <p:nvPr/>
         </p:nvSpPr>
         <p:spPr>
           <a:xfrm>
-            <a:off x="3530680" y="1355219"/>
-            <a:ext cx="920373" cy="224664"/>
+            <a:off x="2960814" y="2514365"/>
+            <a:ext cx="224315" cy="169507"/>
           </a:xfrm>
           <a:prstGeom prst="rect">
             <a:avLst/>
@@ -894,7 +826,7 @@
                 <a:ea typeface="trebuchet ms"/>
                 <a:cs typeface="trebuchet ms"/>
               </a:rPr>
-              <a:t>3D Mesh 轉換</a:t>
+              <a:t>NG</a:t>
             </a:r>
             <a:endParaRPr lang="en-US" sz="1200"/>
           </a:p>
@@ -902,38 +834,14 @@
       </p:sp>
       <p:sp>
         <p:nvSpPr>
-          <p:cNvPr id="17" name="Rect 17"/>
-          <p:cNvSpPr/>
-          <p:nvPr/>
-        </p:nvSpPr>
-        <p:spPr>
-          <a:xfrm>
-            <a:off x="988034" y="2188348"/>
-            <a:ext cx="1657482" cy="505493"/>
-          </a:xfrm>
-          <a:prstGeom prst="rect">
-            <a:avLst/>
-          </a:prstGeom>
-          <a:solidFill>
-            <a:srgbClr val="ECECFF"/>
-          </a:solidFill>
-          <a:ln w="9525">
-            <a:solidFill>
-              <a:srgbClr val="9370DB"/>
-            </a:solidFill>
-          </a:ln>
-        </p:spPr>
-      </p:sp>
-      <p:sp>
-        <p:nvSpPr>
-          <p:cNvPr id="18" name="Text 18"/>
+          <p:cNvPr id="14" name="Text 14"/>
           <p:cNvSpPr txBox="1"/>
           <p:nvPr/>
         </p:nvSpPr>
         <p:spPr>
           <a:xfrm>
-            <a:off x="1124436" y="2328762"/>
-            <a:ext cx="1384679" cy="224664"/>
+            <a:off x="2205092" y="4887473"/>
+            <a:ext cx="224315" cy="169507"/>
           </a:xfrm>
           <a:prstGeom prst="rect">
             <a:avLst/>
@@ -959,7 +867,7 @@
                 <a:ea typeface="trebuchet ms"/>
                 <a:cs typeface="trebuchet ms"/>
               </a:rPr>
-              <a:t>PLC / Controller</a:t>
+              <a:t>OK</a:t>
             </a:r>
             <a:endParaRPr lang="en-US" sz="1200"/>
           </a:p>
@@ -967,38 +875,14 @@
       </p:sp>
       <p:sp>
         <p:nvSpPr>
-          <p:cNvPr id="19" name="Rect 19"/>
-          <p:cNvSpPr/>
-          <p:nvPr/>
-        </p:nvSpPr>
-        <p:spPr>
-          <a:xfrm>
-            <a:off x="3295301" y="2675119"/>
-            <a:ext cx="1391131" cy="505494"/>
-          </a:xfrm>
-          <a:prstGeom prst="rect">
-            <a:avLst/>
-          </a:prstGeom>
-          <a:solidFill>
-            <a:srgbClr val="ECECFF"/>
-          </a:solidFill>
-          <a:ln w="9525">
-            <a:solidFill>
-              <a:srgbClr val="9370DB"/>
-            </a:solidFill>
-          </a:ln>
-        </p:spPr>
-      </p:sp>
-      <p:sp>
-        <p:nvSpPr>
-          <p:cNvPr id="20" name="Text 20"/>
+          <p:cNvPr id="15" name="Text 15"/>
           <p:cNvSpPr txBox="1"/>
           <p:nvPr/>
         </p:nvSpPr>
         <p:spPr>
           <a:xfrm>
-            <a:off x="3576131" y="2815534"/>
-            <a:ext cx="829472" cy="224664"/>
+            <a:off x="3088120" y="4887473"/>
+            <a:ext cx="329410" cy="169507"/>
           </a:xfrm>
           <a:prstGeom prst="rect">
             <a:avLst/>
@@ -1024,7 +908,7 @@
                 <a:ea typeface="trebuchet ms"/>
                 <a:cs typeface="trebuchet ms"/>
               </a:rPr>
-              <a:t>OT 資料接入</a:t>
+              <a:t>仍 NG</a:t>
             </a:r>
             <a:endParaRPr lang="en-US" sz="1200"/>
           </a:p>
@@ -1032,14 +916,14 @@
       </p:sp>
       <p:sp>
         <p:nvSpPr>
-          <p:cNvPr id="21" name="Rect 21"/>
-          <p:cNvSpPr/>
-          <p:nvPr/>
-        </p:nvSpPr>
-        <p:spPr>
-          <a:xfrm>
-            <a:off x="899032" y="3161891"/>
-            <a:ext cx="1835486" cy="505494"/>
+          <p:cNvPr id="16" name="Rect 16"/>
+          <p:cNvSpPr/>
+          <p:nvPr/>
+        </p:nvSpPr>
+        <p:spPr>
+          <a:xfrm>
+            <a:off x="1946202" y="487335"/>
+            <a:ext cx="1101801" cy="381392"/>
           </a:xfrm>
           <a:prstGeom prst="rect">
             <a:avLst/>
@@ -1056,14 +940,14 @@
       </p:sp>
       <p:sp>
         <p:nvSpPr>
-          <p:cNvPr id="22" name="Text 22"/>
+          <p:cNvPr id="17" name="Text 17"/>
           <p:cNvSpPr txBox="1"/>
           <p:nvPr/>
         </p:nvSpPr>
         <p:spPr>
           <a:xfrm>
-            <a:off x="1028580" y="3302306"/>
-            <a:ext cx="1576392" cy="224664"/>
+            <a:off x="2158087" y="593277"/>
+            <a:ext cx="678031" cy="169508"/>
           </a:xfrm>
           <a:prstGeom prst="rect">
             <a:avLst/>
@@ -1089,7 +973,7 @@
                 <a:ea typeface="trebuchet ms"/>
                 <a:cs typeface="trebuchet ms"/>
               </a:rPr>
-              <a:t>EtherCAT / Modbus</a:t>
+              <a:t>產品進入設備</a:t>
             </a:r>
             <a:endParaRPr lang="en-US" sz="1200"/>
           </a:p>
@@ -1097,14 +981,14 @@
       </p:sp>
       <p:sp>
         <p:nvSpPr>
-          <p:cNvPr id="23" name="Rect 23"/>
-          <p:cNvSpPr/>
-          <p:nvPr/>
-        </p:nvSpPr>
-        <p:spPr>
-          <a:xfrm>
-            <a:off x="836869" y="4135435"/>
-            <a:ext cx="1959812" cy="505494"/>
+          <p:cNvPr id="18" name="Rect 18"/>
+          <p:cNvSpPr/>
+          <p:nvPr/>
+        </p:nvSpPr>
+        <p:spPr>
+          <a:xfrm>
+            <a:off x="1946202" y="1221868"/>
+            <a:ext cx="1101801" cy="381393"/>
           </a:xfrm>
           <a:prstGeom prst="rect">
             <a:avLst/>
@@ -1121,14 +1005,14 @@
       </p:sp>
       <p:sp>
         <p:nvSpPr>
-          <p:cNvPr id="24" name="Text 24"/>
+          <p:cNvPr id="19" name="Text 19"/>
           <p:cNvSpPr txBox="1"/>
           <p:nvPr/>
         </p:nvSpPr>
         <p:spPr>
           <a:xfrm>
-            <a:off x="1049548" y="4275850"/>
-            <a:ext cx="1534455" cy="224664"/>
+            <a:off x="2158087" y="1327811"/>
+            <a:ext cx="678031" cy="169507"/>
           </a:xfrm>
           <a:prstGeom prst="rect">
             <a:avLst/>
@@ -1154,7 +1038,7 @@
                 <a:ea typeface="trebuchet ms"/>
                 <a:cs typeface="trebuchet ms"/>
               </a:rPr>
-              <a:t>MES / 工單 / Routing</a:t>
+              <a:t>拍攝檢測影像</a:t>
             </a:r>
             <a:endParaRPr lang="en-US" sz="1200"/>
           </a:p>
@@ -1162,14 +1046,14 @@
       </p:sp>
       <p:sp>
         <p:nvSpPr>
-          <p:cNvPr id="25" name="Rect 25"/>
-          <p:cNvSpPr/>
-          <p:nvPr/>
-        </p:nvSpPr>
-        <p:spPr>
-          <a:xfrm>
-            <a:off x="3324919" y="4622207"/>
-            <a:ext cx="1331895" cy="505493"/>
+          <p:cNvPr id="20" name="Rect 20"/>
+          <p:cNvSpPr/>
+          <p:nvPr/>
+        </p:nvSpPr>
+        <p:spPr>
+          <a:xfrm>
+            <a:off x="1776695" y="1956402"/>
+            <a:ext cx="1440815" cy="381392"/>
           </a:xfrm>
           <a:prstGeom prst="rect">
             <a:avLst/>
@@ -1186,14 +1070,14 @@
       </p:sp>
       <p:sp>
         <p:nvSpPr>
-          <p:cNvPr id="26" name="Text 26"/>
+          <p:cNvPr id="21" name="Text 21"/>
           <p:cNvSpPr txBox="1"/>
           <p:nvPr/>
         </p:nvSpPr>
         <p:spPr>
           <a:xfrm>
-            <a:off x="3605749" y="4762622"/>
-            <a:ext cx="770235" cy="224664"/>
+            <a:off x="1988579" y="2062344"/>
+            <a:ext cx="1017047" cy="169508"/>
           </a:xfrm>
           <a:prstGeom prst="rect">
             <a:avLst/>
@@ -1219,7 +1103,7 @@
                 <a:ea typeface="trebuchet ms"/>
                 <a:cs typeface="trebuchet ms"/>
               </a:rPr>
-              <a:t>IT 資料接入</a:t>
+              <a:t>判定是否有髒污缺陷</a:t>
             </a:r>
             <a:endParaRPr lang="en-US" sz="1200"/>
           </a:p>
@@ -1227,14 +1111,14 @@
       </p:sp>
       <p:sp>
         <p:nvSpPr>
-          <p:cNvPr id="27" name="Rect 27"/>
-          <p:cNvSpPr/>
-          <p:nvPr/>
-        </p:nvSpPr>
-        <p:spPr>
-          <a:xfrm>
-            <a:off x="856615" y="5108978"/>
-            <a:ext cx="1920320" cy="505494"/>
+          <p:cNvPr id="22" name="Rect 22"/>
+          <p:cNvSpPr/>
+          <p:nvPr/>
+        </p:nvSpPr>
+        <p:spPr>
+          <a:xfrm>
+            <a:off x="1303486" y="5233551"/>
+            <a:ext cx="875790" cy="381392"/>
           </a:xfrm>
           <a:prstGeom prst="rect">
             <a:avLst/>
@@ -1251,14 +1135,14 @@
       </p:sp>
       <p:sp>
         <p:nvSpPr>
-          <p:cNvPr id="28" name="Text 28"/>
+          <p:cNvPr id="23" name="Text 23"/>
           <p:cNvSpPr txBox="1"/>
           <p:nvPr/>
         </p:nvSpPr>
         <p:spPr>
           <a:xfrm>
-            <a:off x="1137445" y="5249393"/>
-            <a:ext cx="1358661" cy="224664"/>
+            <a:off x="1515370" y="5339493"/>
+            <a:ext cx="452021" cy="169508"/>
           </a:xfrm>
           <a:prstGeom prst="rect">
             <a:avLst/>
@@ -1284,7 +1168,7 @@
                 <a:ea typeface="trebuchet ms"/>
                 <a:cs typeface="trebuchet ms"/>
               </a:rPr>
-              <a:t>SCADA / 警報 / 狀態</a:t>
+              <a:t>通過檢測</a:t>
             </a:r>
             <a:endParaRPr lang="en-US" sz="1200"/>
           </a:p>
@@ -1292,14 +1176,14 @@
       </p:sp>
       <p:sp>
         <p:nvSpPr>
-          <p:cNvPr id="29" name="Rect 29"/>
-          <p:cNvSpPr/>
-          <p:nvPr/>
-        </p:nvSpPr>
-        <p:spPr>
-          <a:xfrm>
-            <a:off x="5185052" y="2675119"/>
-            <a:ext cx="1460315" cy="505494"/>
+          <p:cNvPr id="24" name="Rect 24"/>
+          <p:cNvSpPr/>
+          <p:nvPr/>
+        </p:nvSpPr>
+        <p:spPr>
+          <a:xfrm>
+            <a:off x="2522071" y="2860443"/>
+            <a:ext cx="1101800" cy="381392"/>
           </a:xfrm>
           <a:prstGeom prst="rect">
             <a:avLst/>
@@ -1316,14 +1200,14 @@
       </p:sp>
       <p:sp>
         <p:nvSpPr>
-          <p:cNvPr id="30" name="Text 30"/>
+          <p:cNvPr id="25" name="Text 25"/>
           <p:cNvSpPr txBox="1"/>
           <p:nvPr/>
         </p:nvSpPr>
         <p:spPr>
           <a:xfrm>
-            <a:off x="5465882" y="2815534"/>
-            <a:ext cx="898655" cy="224664"/>
+            <a:off x="2733955" y="2966385"/>
+            <a:ext cx="678031" cy="169508"/>
           </a:xfrm>
           <a:prstGeom prst="rect">
             <a:avLst/>
@@ -1349,7 +1233,7 @@
                 <a:ea typeface="trebuchet ms"/>
                 <a:cs typeface="trebuchet ms"/>
               </a:rPr>
-              <a:t>數位孿生核心</a:t>
+              <a:t>定位髒污位置</a:t>
             </a:r>
             <a:endParaRPr lang="en-US" sz="1200"/>
           </a:p>
@@ -1357,14 +1241,14 @@
       </p:sp>
       <p:sp>
         <p:nvSpPr>
-          <p:cNvPr id="31" name="Rect 31"/>
-          <p:cNvSpPr/>
-          <p:nvPr/>
-        </p:nvSpPr>
-        <p:spPr>
-          <a:xfrm>
-            <a:off x="7113417" y="2188348"/>
-            <a:ext cx="1675911" cy="505493"/>
+          <p:cNvPr id="26" name="Rect 26"/>
+          <p:cNvSpPr/>
+          <p:nvPr/>
+        </p:nvSpPr>
+        <p:spPr>
+          <a:xfrm>
+            <a:off x="2635076" y="3594976"/>
+            <a:ext cx="875790" cy="381393"/>
           </a:xfrm>
           <a:prstGeom prst="rect">
             <a:avLst/>
@@ -1381,14 +1265,14 @@
       </p:sp>
       <p:sp>
         <p:nvSpPr>
-          <p:cNvPr id="32" name="Text 32"/>
+          <p:cNvPr id="27" name="Text 27"/>
           <p:cNvSpPr txBox="1"/>
           <p:nvPr/>
         </p:nvSpPr>
         <p:spPr>
           <a:xfrm>
-            <a:off x="7394247" y="2328762"/>
-            <a:ext cx="1114251" cy="224664"/>
+            <a:off x="2846961" y="3700919"/>
+            <a:ext cx="452020" cy="169507"/>
           </a:xfrm>
           <a:prstGeom prst="rect">
             <a:avLst/>
@@ -1414,7 +1298,7 @@
                 <a:ea typeface="trebuchet ms"/>
                 <a:cs typeface="trebuchet ms"/>
               </a:rPr>
-              <a:t>3D 即時操作介面</a:t>
+              <a:t>自動清潔</a:t>
             </a:r>
             <a:endParaRPr lang="en-US" sz="1200"/>
           </a:p>
@@ -1422,14 +1306,14 @@
       </p:sp>
       <p:sp>
         <p:nvSpPr>
-          <p:cNvPr id="33" name="Rect 33"/>
-          <p:cNvSpPr/>
-          <p:nvPr/>
-        </p:nvSpPr>
-        <p:spPr>
-          <a:xfrm>
-            <a:off x="7391395" y="3161891"/>
-            <a:ext cx="1119955" cy="505494"/>
+          <p:cNvPr id="28" name="Rect 28"/>
+          <p:cNvSpPr/>
+          <p:nvPr/>
+        </p:nvSpPr>
+        <p:spPr>
+          <a:xfrm>
+            <a:off x="2522071" y="4329510"/>
+            <a:ext cx="1101800" cy="381392"/>
           </a:xfrm>
           <a:prstGeom prst="rect">
             <a:avLst/>
@@ -1446,14 +1330,14 @@
       </p:sp>
       <p:sp>
         <p:nvSpPr>
-          <p:cNvPr id="34" name="Text 34"/>
+          <p:cNvPr id="29" name="Text 29"/>
           <p:cNvSpPr txBox="1"/>
           <p:nvPr/>
         </p:nvSpPr>
         <p:spPr>
           <a:xfrm>
-            <a:off x="7638715" y="3302306"/>
-            <a:ext cx="625315" cy="224664"/>
+            <a:off x="2733955" y="4435452"/>
+            <a:ext cx="678031" cy="169508"/>
           </a:xfrm>
           <a:prstGeom prst="rect">
             <a:avLst/>
@@ -1479,7 +1363,7 @@
                 <a:ea typeface="trebuchet ms"/>
                 <a:cs typeface="trebuchet ms"/>
               </a:rPr>
-              <a:t>整合 API</a:t>
+              <a:t>再次檢測確認</a:t>
             </a:r>
             <a:endParaRPr lang="en-US" sz="1200"/>
           </a:p>
@@ -1487,14 +1371,14 @@
       </p:sp>
       <p:sp>
         <p:nvSpPr>
-          <p:cNvPr id="35" name="Rect 35"/>
-          <p:cNvSpPr/>
-          <p:nvPr/>
-        </p:nvSpPr>
-        <p:spPr>
-          <a:xfrm>
-            <a:off x="9257378" y="2188348"/>
-            <a:ext cx="2097448" cy="505493"/>
+          <p:cNvPr id="30" name="Rect 30"/>
+          <p:cNvSpPr/>
+          <p:nvPr/>
+        </p:nvSpPr>
+        <p:spPr>
+          <a:xfrm>
+            <a:off x="2532417" y="5233551"/>
+            <a:ext cx="1440815" cy="381392"/>
           </a:xfrm>
           <a:prstGeom prst="rect">
             <a:avLst/>
@@ -1511,14 +1395,14 @@
       </p:sp>
       <p:sp>
         <p:nvSpPr>
-          <p:cNvPr id="36" name="Text 36"/>
+          <p:cNvPr id="31" name="Text 31"/>
           <p:cNvSpPr txBox="1"/>
           <p:nvPr/>
         </p:nvSpPr>
         <p:spPr>
           <a:xfrm>
-            <a:off x="9538208" y="2328762"/>
-            <a:ext cx="1535788" cy="224664"/>
+            <a:off x="2744301" y="5339493"/>
+            <a:ext cx="1017047" cy="169508"/>
           </a:xfrm>
           <a:prstGeom prst="rect">
             <a:avLst/>
@@ -1544,7 +1428,72 @@
                 <a:ea typeface="trebuchet ms"/>
                 <a:cs typeface="trebuchet ms"/>
               </a:rPr>
-              <a:t>工程師 / 操作員 / 主管</a:t>
+              <a:t>保留紀錄並提示處理</a:t>
+            </a:r>
+            <a:endParaRPr lang="en-US" sz="1200"/>
+          </a:p>
+        </p:txBody>
+      </p:sp>
+      <p:sp>
+        <p:nvSpPr>
+          <p:cNvPr id="32" name="Rect 32"/>
+          <p:cNvSpPr/>
+          <p:nvPr/>
+        </p:nvSpPr>
+        <p:spPr>
+          <a:xfrm>
+            <a:off x="1946202" y="5968084"/>
+            <a:ext cx="1101801" cy="381393"/>
+          </a:xfrm>
+          <a:prstGeom prst="rect">
+            <a:avLst/>
+          </a:prstGeom>
+          <a:solidFill>
+            <a:srgbClr val="ECECFF"/>
+          </a:solidFill>
+          <a:ln w="9525">
+            <a:solidFill>
+              <a:srgbClr val="9370DB"/>
+            </a:solidFill>
+          </a:ln>
+        </p:spPr>
+      </p:sp>
+      <p:sp>
+        <p:nvSpPr>
+          <p:cNvPr id="33" name="Text 33"/>
+          <p:cNvSpPr txBox="1"/>
+          <p:nvPr/>
+        </p:nvSpPr>
+        <p:spPr>
+          <a:xfrm>
+            <a:off x="2158087" y="6074027"/>
+            <a:ext cx="678031" cy="169508"/>
+          </a:xfrm>
+          <a:prstGeom prst="rect">
+            <a:avLst/>
+          </a:prstGeom>
+          <a:noFill/>
+          <a:ln w="9525">
+            <a:noFill/>
+          </a:ln>
+        </p:spPr>
+        <p:txBody>
+          <a:bodyPr wrap="none" rtlCol="0" lIns="0" tIns="0" rIns="0" bIns="0" anchor="ctr">
+            <a:noAutofit/>
+          </a:bodyPr>
+          <a:lstStyle/>
+          <a:p>
+            <a:pPr algn="ctr"/>
+            <a:r>
+              <a:rPr lang="en-US" sz="1200">
+                <a:solidFill>
+                  <a:srgbClr val="333333"/>
+                </a:solidFill>
+                <a:latin typeface="trebuchet ms"/>
+                <a:ea typeface="trebuchet ms"/>
+                <a:cs typeface="trebuchet ms"/>
+              </a:rPr>
+              <a:t>產出檢測紀錄</a:t>
             </a:r>
             <a:endParaRPr lang="en-US" sz="1200"/>
           </a:p>

</xml_diff>